<commit_message>
feat: update SpecStyle Track 1 submission
</commit_message>
<xml_diff>
--- a/SpecStyle/submission/track1-specstyle/SpecStyle_Track1_Deck.pptx
+++ b/SpecStyle/submission/track1-specstyle/SpecStyle_Track1_Deck.pptx
@@ -2,21 +2,21 @@
 <file path=ppt/presentation.xml><?xml version="1.0" encoding="utf-8"?>
 <p:presentation xmlns:p="http://schemas.openxmlformats.org/presentationml/2006/main">
   <p:sldMasterIdLst>
-    <p:sldMasterId xmlns:r="http://schemas.openxmlformats.org/officeDocument/2006/relationships" id="2147483648" r:id="R97a72a7b594c4802"/>
+    <p:sldMasterId xmlns:r="http://schemas.openxmlformats.org/officeDocument/2006/relationships" id="2147483648" r:id="R098c7087255e4545"/>
   </p:sldMasterIdLst>
   <p:notesMasterIdLst>
-    <p:notesMasterId xmlns:r="http://schemas.openxmlformats.org/officeDocument/2006/relationships" r:id="Rba680c23b12d4cb5"/>
+    <p:notesMasterId xmlns:r="http://schemas.openxmlformats.org/officeDocument/2006/relationships" r:id="R59e2d52d83834d86"/>
   </p:notesMasterIdLst>
   <p:sldIdLst>
-    <p:sldId xmlns:r="http://schemas.openxmlformats.org/officeDocument/2006/relationships" id="256" r:id="Rb1524eba946e44e2"/>
-    <p:sldId xmlns:r="http://schemas.openxmlformats.org/officeDocument/2006/relationships" id="257" r:id="R66018c751c3649ec"/>
-    <p:sldId xmlns:r="http://schemas.openxmlformats.org/officeDocument/2006/relationships" id="258" r:id="R1773c77418a34356"/>
-    <p:sldId xmlns:r="http://schemas.openxmlformats.org/officeDocument/2006/relationships" id="259" r:id="R972910a98198465a"/>
-    <p:sldId xmlns:r="http://schemas.openxmlformats.org/officeDocument/2006/relationships" id="260" r:id="Ree083be337d34c28"/>
-    <p:sldId xmlns:r="http://schemas.openxmlformats.org/officeDocument/2006/relationships" id="261" r:id="Rdf45ec82b96246a5"/>
-    <p:sldId xmlns:r="http://schemas.openxmlformats.org/officeDocument/2006/relationships" id="262" r:id="Rd28770ee528b42fc"/>
-    <p:sldId xmlns:r="http://schemas.openxmlformats.org/officeDocument/2006/relationships" id="263" r:id="Rb417dd942b89472d"/>
-    <p:sldId xmlns:r="http://schemas.openxmlformats.org/officeDocument/2006/relationships" id="264" r:id="R78dcb558aa2f4d82"/>
+    <p:sldId xmlns:r="http://schemas.openxmlformats.org/officeDocument/2006/relationships" id="256" r:id="Rfb95db3a7f5e461b"/>
+    <p:sldId xmlns:r="http://schemas.openxmlformats.org/officeDocument/2006/relationships" id="257" r:id="R661700a71cd34fc4"/>
+    <p:sldId xmlns:r="http://schemas.openxmlformats.org/officeDocument/2006/relationships" id="258" r:id="R179726e846384cc8"/>
+    <p:sldId xmlns:r="http://schemas.openxmlformats.org/officeDocument/2006/relationships" id="259" r:id="R22cfa0b10c774048"/>
+    <p:sldId xmlns:r="http://schemas.openxmlformats.org/officeDocument/2006/relationships" id="260" r:id="R4aaca45c97b64350"/>
+    <p:sldId xmlns:r="http://schemas.openxmlformats.org/officeDocument/2006/relationships" id="261" r:id="R950a39d092a24f3d"/>
+    <p:sldId xmlns:r="http://schemas.openxmlformats.org/officeDocument/2006/relationships" id="262" r:id="R78623db371364ae8"/>
+    <p:sldId xmlns:r="http://schemas.openxmlformats.org/officeDocument/2006/relationships" id="263" r:id="Rf1d8fae351884ed5"/>
+    <p:sldId xmlns:r="http://schemas.openxmlformats.org/officeDocument/2006/relationships" id="264" r:id="Rc4966a365b724a91"/>
   </p:sldIdLst>
   <p:sldSz cx="12192000" cy="6858000"/>
   <p:notesSz cx="6858000" cy="9144000"/>
@@ -1137,7 +1137,7 @@
   </p:cSld>
   <p:clrMap bg1="lt1" tx1="dk1" bg2="lt2" tx2="dk2" accent1="accent1" accent2="accent2" accent3="accent3" accent4="accent4" accent5="accent5" accent6="accent6" hlink="hlink" folHlink="folHlink"/>
   <p:sldLayoutIdLst>
-    <p:sldLayoutId xmlns:r="http://schemas.openxmlformats.org/officeDocument/2006/relationships" id="2147483649" r:id="Rf3decee6bff74e89"/>
+    <p:sldLayoutId xmlns:r="http://schemas.openxmlformats.org/officeDocument/2006/relationships" id="2147483649" r:id="Re747475e2c404b9d"/>
   </p:sldLayoutIdLst>
   <p:txStyles>
     <p:titleStyle>
@@ -1806,6 +1806,7 @@
           <a:lstStyle xmlns:a="http://schemas.openxmlformats.org/drawingml/2006/main"/>
           <a:p xmlns:a="http://schemas.openxmlformats.org/drawingml/2006/main">
             <a:pPr algn="l">
+              <a:buNone/>
               <a:defRPr sz="5400" b="1">
                 <a:solidFill>
                   <a:srgbClr val="15171A"/>
@@ -1851,6 +1852,7 @@
           <a:lstStyle xmlns:a="http://schemas.openxmlformats.org/drawingml/2006/main"/>
           <a:p xmlns:a="http://schemas.openxmlformats.org/drawingml/2006/main">
             <a:pPr algn="l">
+              <a:buNone/>
               <a:defRPr sz="2550" b="0">
                 <a:solidFill>
                   <a:srgbClr val="15171A"/>
@@ -1896,6 +1898,7 @@
           <a:lstStyle xmlns:a="http://schemas.openxmlformats.org/drawingml/2006/main"/>
           <a:p xmlns:a="http://schemas.openxmlformats.org/drawingml/2006/main">
             <a:pPr algn="l">
+              <a:buNone/>
               <a:defRPr sz="1800" b="0">
                 <a:solidFill>
                   <a:srgbClr val="606770"/>
@@ -1948,7 +1951,7 @@
       </p:sp>
       <p:cxnSp>
         <p:nvCxnSpPr>
-          <p:cNvPr id="19" name=""/>
+          <p:cNvPr id="37" name=""/>
           <p:cNvCxnSpPr/>
           <p:nvPr/>
         </p:nvCxnSpPr>
@@ -1998,6 +2001,7 @@
           <a:lstStyle xmlns:a="http://schemas.openxmlformats.org/drawingml/2006/main"/>
           <a:p xmlns:a="http://schemas.openxmlformats.org/drawingml/2006/main">
             <a:pPr algn="l">
+              <a:buNone/>
               <a:defRPr sz="1275" b="1">
                 <a:solidFill>
                   <a:srgbClr val="15171A"/>
@@ -2008,7 +2012,7 @@
               </a:defRPr>
             </a:pPr>
             <a:r>
-              <a:t>AMD AI DevMaster | Track 1</a:t>
+              <a:t>Submitted by guan | AMD AI DevMaster | Track 1</a:t>
             </a:r>
           </a:p>
         </p:txBody>
@@ -2043,6 +2047,7 @@
           <a:lstStyle xmlns:a="http://schemas.openxmlformats.org/drawingml/2006/main"/>
           <a:p xmlns:a="http://schemas.openxmlformats.org/drawingml/2006/main">
             <a:pPr algn="r">
+              <a:buNone/>
               <a:defRPr sz="1275" b="0">
                 <a:solidFill>
                   <a:srgbClr val="606770"/>
@@ -2060,14 +2065,14 @@
       </p:sp>
       <p:pic>
         <p:nvPicPr>
-          <p:cNvPr id="22" name=""/>
+          <p:cNvPr id="40" name=""/>
           <p:cNvPicPr>
             <a:picLocks xmlns:a="http://schemas.openxmlformats.org/drawingml/2006/main" noChangeAspect="1"/>
           </p:cNvPicPr>
           <p:nvPr/>
         </p:nvPicPr>
         <p:blipFill>
-          <a:blip xmlns:r="http://schemas.openxmlformats.org/officeDocument/2006/relationships" xmlns:a="http://schemas.openxmlformats.org/drawingml/2006/main" r:embed="R8c2c4637b31b4d0c"/>
+          <a:blip xmlns:r="http://schemas.openxmlformats.org/officeDocument/2006/relationships" xmlns:a="http://schemas.openxmlformats.org/drawingml/2006/main" r:embed="Rd818cbe47f104e82"/>
           <a:srcRect xmlns:a="http://schemas.openxmlformats.org/drawingml/2006/main" l="0" t="358" r="0" b="358"/>
           <a:stretch xmlns:a="http://schemas.openxmlformats.org/drawingml/2006/main">
             <a:fillRect l="0" t="0" r="0" b="0"/>
@@ -2144,6 +2149,7 @@
           <a:lstStyle xmlns:a="http://schemas.openxmlformats.org/drawingml/2006/main"/>
           <a:p xmlns:a="http://schemas.openxmlformats.org/drawingml/2006/main">
             <a:pPr algn="l">
+              <a:buNone/>
               <a:defRPr sz="1125" b="1">
                 <a:solidFill>
                   <a:srgbClr val="606770"/>
@@ -2189,6 +2195,7 @@
           <a:lstStyle xmlns:a="http://schemas.openxmlformats.org/drawingml/2006/main"/>
           <a:p xmlns:a="http://schemas.openxmlformats.org/drawingml/2006/main">
             <a:pPr algn="l">
+              <a:buNone/>
               <a:defRPr sz="3600" b="1">
                 <a:solidFill>
                   <a:srgbClr val="15171A"/>
@@ -2206,7 +2213,7 @@
       </p:sp>
       <p:cxnSp>
         <p:nvCxnSpPr>
-          <p:cNvPr id="20" name=""/>
+          <p:cNvPr id="28" name=""/>
           <p:cNvCxnSpPr/>
           <p:nvPr/>
         </p:nvCxnSpPr>
@@ -2256,6 +2263,7 @@
           <a:lstStyle xmlns:a="http://schemas.openxmlformats.org/drawingml/2006/main"/>
           <a:p xmlns:a="http://schemas.openxmlformats.org/drawingml/2006/main">
             <a:pPr algn="l">
+              <a:buNone/>
               <a:defRPr sz="1050" b="0">
                 <a:solidFill>
                   <a:srgbClr val="606770"/>
@@ -2301,6 +2309,7 @@
           <a:lstStyle xmlns:a="http://schemas.openxmlformats.org/drawingml/2006/main"/>
           <a:p xmlns:a="http://schemas.openxmlformats.org/drawingml/2006/main">
             <a:pPr algn="r">
+              <a:buNone/>
               <a:defRPr sz="1050" b="0">
                 <a:solidFill>
                   <a:srgbClr val="606770"/>
@@ -2381,6 +2390,7 @@
           <a:lstStyle xmlns:a="http://schemas.openxmlformats.org/drawingml/2006/main"/>
           <a:p xmlns:a="http://schemas.openxmlformats.org/drawingml/2006/main">
             <a:pPr algn="l">
+              <a:buNone/>
               <a:defRPr sz="1875" b="1">
                 <a:solidFill>
                   <a:srgbClr val="15171A"/>
@@ -2426,6 +2436,7 @@
           <a:lstStyle xmlns:a="http://schemas.openxmlformats.org/drawingml/2006/main"/>
           <a:p xmlns:a="http://schemas.openxmlformats.org/drawingml/2006/main">
             <a:pPr algn="l">
+              <a:buNone/>
               <a:defRPr sz="1725" b="0">
                 <a:solidFill>
                   <a:srgbClr val="606770"/>
@@ -2502,6 +2513,7 @@
           <a:lstStyle xmlns:a="http://schemas.openxmlformats.org/drawingml/2006/main"/>
           <a:p xmlns:a="http://schemas.openxmlformats.org/drawingml/2006/main">
             <a:pPr algn="l">
+              <a:buNone/>
               <a:defRPr sz="1575" b="0">
                 <a:solidFill>
                   <a:srgbClr val="15171A"/>
@@ -2578,6 +2590,7 @@
           <a:lstStyle xmlns:a="http://schemas.openxmlformats.org/drawingml/2006/main"/>
           <a:p xmlns:a="http://schemas.openxmlformats.org/drawingml/2006/main">
             <a:pPr algn="l">
+              <a:buNone/>
               <a:defRPr sz="1575" b="0">
                 <a:solidFill>
                   <a:srgbClr val="15171A"/>
@@ -2654,6 +2667,7 @@
           <a:lstStyle xmlns:a="http://schemas.openxmlformats.org/drawingml/2006/main"/>
           <a:p xmlns:a="http://schemas.openxmlformats.org/drawingml/2006/main">
             <a:pPr algn="l">
+              <a:buNone/>
               <a:defRPr sz="1575" b="0">
                 <a:solidFill>
                   <a:srgbClr val="15171A"/>
@@ -2730,6 +2744,7 @@
           <a:lstStyle xmlns:a="http://schemas.openxmlformats.org/drawingml/2006/main"/>
           <a:p xmlns:a="http://schemas.openxmlformats.org/drawingml/2006/main">
             <a:pPr algn="l">
+              <a:buNone/>
               <a:defRPr sz="1575" b="0">
                 <a:solidFill>
                   <a:srgbClr val="15171A"/>
@@ -2747,14 +2762,14 @@
       </p:sp>
       <p:pic>
         <p:nvPicPr>
-          <p:cNvPr id="34" name=""/>
+          <p:cNvPr id="42" name=""/>
           <p:cNvPicPr>
             <a:picLocks xmlns:a="http://schemas.openxmlformats.org/drawingml/2006/main" noChangeAspect="1"/>
           </p:cNvPicPr>
           <p:nvPr/>
         </p:nvPicPr>
         <p:blipFill>
-          <a:blip xmlns:r="http://schemas.openxmlformats.org/officeDocument/2006/relationships" xmlns:a="http://schemas.openxmlformats.org/drawingml/2006/main" r:embed="R577ea3e239064444"/>
+          <a:blip xmlns:r="http://schemas.openxmlformats.org/officeDocument/2006/relationships" xmlns:a="http://schemas.openxmlformats.org/drawingml/2006/main" r:embed="R3080bc45fb2e4eff"/>
           <a:stretch xmlns:a="http://schemas.openxmlformats.org/drawingml/2006/main"/>
         </p:blipFill>
         <p:spPr>
@@ -2828,6 +2843,7 @@
           <a:lstStyle xmlns:a="http://schemas.openxmlformats.org/drawingml/2006/main"/>
           <a:p xmlns:a="http://schemas.openxmlformats.org/drawingml/2006/main">
             <a:pPr algn="l">
+              <a:buNone/>
               <a:defRPr sz="1125" b="1">
                 <a:solidFill>
                   <a:srgbClr val="606770"/>
@@ -2873,6 +2889,7 @@
           <a:lstStyle xmlns:a="http://schemas.openxmlformats.org/drawingml/2006/main"/>
           <a:p xmlns:a="http://schemas.openxmlformats.org/drawingml/2006/main">
             <a:pPr algn="l">
+              <a:buNone/>
               <a:defRPr sz="3600" b="1">
                 <a:solidFill>
                   <a:srgbClr val="15171A"/>
@@ -2890,7 +2907,7 @@
       </p:sp>
       <p:cxnSp>
         <p:nvCxnSpPr>
-          <p:cNvPr id="40" name=""/>
+          <p:cNvPr id="52" name=""/>
           <p:cNvCxnSpPr/>
           <p:nvPr/>
         </p:nvCxnSpPr>
@@ -2940,6 +2957,7 @@
           <a:lstStyle xmlns:a="http://schemas.openxmlformats.org/drawingml/2006/main"/>
           <a:p xmlns:a="http://schemas.openxmlformats.org/drawingml/2006/main">
             <a:pPr algn="l">
+              <a:buNone/>
               <a:defRPr sz="1050" b="0">
                 <a:solidFill>
                   <a:srgbClr val="606770"/>
@@ -2985,6 +3003,7 @@
           <a:lstStyle xmlns:a="http://schemas.openxmlformats.org/drawingml/2006/main"/>
           <a:p xmlns:a="http://schemas.openxmlformats.org/drawingml/2006/main">
             <a:pPr algn="r">
+              <a:buNone/>
               <a:defRPr sz="1050" b="0">
                 <a:solidFill>
                   <a:srgbClr val="606770"/>
@@ -3002,7 +3021,7 @@
       </p:sp>
       <p:cxnSp>
         <p:nvCxnSpPr>
-          <p:cNvPr id="43" name=""/>
+          <p:cNvPr id="55" name=""/>
           <p:cNvCxnSpPr/>
           <p:nvPr/>
         </p:nvCxnSpPr>
@@ -3118,6 +3137,7 @@
           <a:lstStyle xmlns:a="http://schemas.openxmlformats.org/drawingml/2006/main"/>
           <a:p xmlns:a="http://schemas.openxmlformats.org/drawingml/2006/main">
             <a:pPr algn="l">
+              <a:buNone/>
               <a:defRPr sz="1275" b="1">
                 <a:solidFill>
                   <a:srgbClr val="2F6BFF"/>
@@ -3163,6 +3183,7 @@
           <a:lstStyle xmlns:a="http://schemas.openxmlformats.org/drawingml/2006/main"/>
           <a:p xmlns:a="http://schemas.openxmlformats.org/drawingml/2006/main">
             <a:pPr algn="l">
+              <a:buNone/>
               <a:defRPr sz="1875" b="1">
                 <a:solidFill>
                   <a:srgbClr val="15171A"/>
@@ -3208,6 +3229,7 @@
           <a:lstStyle xmlns:a="http://schemas.openxmlformats.org/drawingml/2006/main"/>
           <a:p xmlns:a="http://schemas.openxmlformats.org/drawingml/2006/main">
             <a:pPr algn="l">
+              <a:buNone/>
               <a:defRPr sz="1275" b="0">
                 <a:solidFill>
                   <a:srgbClr val="606770"/>
@@ -3319,6 +3341,7 @@
           <a:lstStyle xmlns:a="http://schemas.openxmlformats.org/drawingml/2006/main"/>
           <a:p xmlns:a="http://schemas.openxmlformats.org/drawingml/2006/main">
             <a:pPr algn="l">
+              <a:buNone/>
               <a:defRPr sz="1275" b="1">
                 <a:solidFill>
                   <a:srgbClr val="F4C84A"/>
@@ -3364,6 +3387,7 @@
           <a:lstStyle xmlns:a="http://schemas.openxmlformats.org/drawingml/2006/main"/>
           <a:p xmlns:a="http://schemas.openxmlformats.org/drawingml/2006/main">
             <a:pPr algn="l">
+              <a:buNone/>
               <a:defRPr sz="1875" b="1">
                 <a:solidFill>
                   <a:srgbClr val="15171A"/>
@@ -3409,6 +3433,7 @@
           <a:lstStyle xmlns:a="http://schemas.openxmlformats.org/drawingml/2006/main"/>
           <a:p xmlns:a="http://schemas.openxmlformats.org/drawingml/2006/main">
             <a:pPr algn="l">
+              <a:buNone/>
               <a:defRPr sz="1275" b="0">
                 <a:solidFill>
                   <a:srgbClr val="606770"/>
@@ -3520,6 +3545,7 @@
           <a:lstStyle xmlns:a="http://schemas.openxmlformats.org/drawingml/2006/main"/>
           <a:p xmlns:a="http://schemas.openxmlformats.org/drawingml/2006/main">
             <a:pPr algn="l">
+              <a:buNone/>
               <a:defRPr sz="1275" b="1">
                 <a:solidFill>
                   <a:srgbClr val="EB5A5A"/>
@@ -3565,6 +3591,7 @@
           <a:lstStyle xmlns:a="http://schemas.openxmlformats.org/drawingml/2006/main"/>
           <a:p xmlns:a="http://schemas.openxmlformats.org/drawingml/2006/main">
             <a:pPr algn="l">
+              <a:buNone/>
               <a:defRPr sz="1875" b="1">
                 <a:solidFill>
                   <a:srgbClr val="15171A"/>
@@ -3610,6 +3637,7 @@
           <a:lstStyle xmlns:a="http://schemas.openxmlformats.org/drawingml/2006/main"/>
           <a:p xmlns:a="http://schemas.openxmlformats.org/drawingml/2006/main">
             <a:pPr algn="l">
+              <a:buNone/>
               <a:defRPr sz="1275" b="0">
                 <a:solidFill>
                   <a:srgbClr val="606770"/>
@@ -3721,6 +3749,7 @@
           <a:lstStyle xmlns:a="http://schemas.openxmlformats.org/drawingml/2006/main"/>
           <a:p xmlns:a="http://schemas.openxmlformats.org/drawingml/2006/main">
             <a:pPr algn="l">
+              <a:buNone/>
               <a:defRPr sz="1275" b="1">
                 <a:solidFill>
                   <a:srgbClr val="2F6BFF"/>
@@ -3766,6 +3795,7 @@
           <a:lstStyle xmlns:a="http://schemas.openxmlformats.org/drawingml/2006/main"/>
           <a:p xmlns:a="http://schemas.openxmlformats.org/drawingml/2006/main">
             <a:pPr algn="l">
+              <a:buNone/>
               <a:defRPr sz="1875" b="1">
                 <a:solidFill>
                   <a:srgbClr val="15171A"/>
@@ -3811,6 +3841,7 @@
           <a:lstStyle xmlns:a="http://schemas.openxmlformats.org/drawingml/2006/main"/>
           <a:p xmlns:a="http://schemas.openxmlformats.org/drawingml/2006/main">
             <a:pPr algn="l">
+              <a:buNone/>
               <a:defRPr sz="1275" b="0">
                 <a:solidFill>
                   <a:srgbClr val="606770"/>
@@ -3922,6 +3953,7 @@
           <a:lstStyle xmlns:a="http://schemas.openxmlformats.org/drawingml/2006/main"/>
           <a:p xmlns:a="http://schemas.openxmlformats.org/drawingml/2006/main">
             <a:pPr algn="l">
+              <a:buNone/>
               <a:defRPr sz="1275" b="1">
                 <a:solidFill>
                   <a:srgbClr val="EB5A5A"/>
@@ -3967,6 +3999,7 @@
           <a:lstStyle xmlns:a="http://schemas.openxmlformats.org/drawingml/2006/main"/>
           <a:p xmlns:a="http://schemas.openxmlformats.org/drawingml/2006/main">
             <a:pPr algn="l">
+              <a:buNone/>
               <a:defRPr sz="1875" b="1">
                 <a:solidFill>
                   <a:srgbClr val="15171A"/>
@@ -4012,6 +4045,7 @@
           <a:lstStyle xmlns:a="http://schemas.openxmlformats.org/drawingml/2006/main"/>
           <a:p xmlns:a="http://schemas.openxmlformats.org/drawingml/2006/main">
             <a:pPr algn="l">
+              <a:buNone/>
               <a:defRPr sz="1275" b="0">
                 <a:solidFill>
                   <a:srgbClr val="606770"/>
@@ -4057,6 +4091,7 @@
           <a:lstStyle xmlns:a="http://schemas.openxmlformats.org/drawingml/2006/main"/>
           <a:p xmlns:a="http://schemas.openxmlformats.org/drawingml/2006/main">
             <a:pPr algn="l">
+              <a:buNone/>
               <a:defRPr sz="1275" b="1">
                 <a:solidFill>
                   <a:srgbClr val="EB5A5A"/>
@@ -4102,6 +4137,7 @@
           <a:lstStyle xmlns:a="http://schemas.openxmlformats.org/drawingml/2006/main"/>
           <a:p xmlns:a="http://schemas.openxmlformats.org/drawingml/2006/main">
             <a:pPr algn="l">
+              <a:buNone/>
               <a:defRPr sz="1575" b="0">
                 <a:solidFill>
                   <a:srgbClr val="15171A"/>
@@ -4147,6 +4183,7 @@
           <a:lstStyle xmlns:a="http://schemas.openxmlformats.org/drawingml/2006/main"/>
           <a:p xmlns:a="http://schemas.openxmlformats.org/drawingml/2006/main">
             <a:pPr algn="l">
+              <a:buNone/>
               <a:defRPr sz="1275" b="1">
                 <a:solidFill>
                   <a:srgbClr val="F4C84A"/>
@@ -4192,6 +4229,7 @@
           <a:lstStyle xmlns:a="http://schemas.openxmlformats.org/drawingml/2006/main"/>
           <a:p xmlns:a="http://schemas.openxmlformats.org/drawingml/2006/main">
             <a:pPr algn="l">
+              <a:buNone/>
               <a:defRPr sz="1575" b="0">
                 <a:solidFill>
                   <a:srgbClr val="15171A"/>
@@ -4237,6 +4275,7 @@
           <a:lstStyle xmlns:a="http://schemas.openxmlformats.org/drawingml/2006/main"/>
           <a:p xmlns:a="http://schemas.openxmlformats.org/drawingml/2006/main">
             <a:pPr algn="l">
+              <a:buNone/>
               <a:defRPr sz="1275" b="1">
                 <a:solidFill>
                   <a:srgbClr val="2F6BFF"/>
@@ -4282,6 +4321,7 @@
           <a:lstStyle xmlns:a="http://schemas.openxmlformats.org/drawingml/2006/main"/>
           <a:p xmlns:a="http://schemas.openxmlformats.org/drawingml/2006/main">
             <a:pPr algn="l">
+              <a:buNone/>
               <a:defRPr sz="1575" b="0">
                 <a:solidFill>
                   <a:srgbClr val="15171A"/>
@@ -4356,6 +4396,7 @@
           <a:lstStyle xmlns:a="http://schemas.openxmlformats.org/drawingml/2006/main"/>
           <a:p xmlns:a="http://schemas.openxmlformats.org/drawingml/2006/main">
             <a:pPr algn="l">
+              <a:buNone/>
               <a:defRPr sz="1125" b="1">
                 <a:solidFill>
                   <a:srgbClr val="606770"/>
@@ -4401,6 +4442,7 @@
           <a:lstStyle xmlns:a="http://schemas.openxmlformats.org/drawingml/2006/main"/>
           <a:p xmlns:a="http://schemas.openxmlformats.org/drawingml/2006/main">
             <a:pPr algn="l">
+              <a:buNone/>
               <a:defRPr sz="3600" b="1">
                 <a:solidFill>
                   <a:srgbClr val="15171A"/>
@@ -4418,7 +4460,7 @@
       </p:sp>
       <p:cxnSp>
         <p:nvCxnSpPr>
-          <p:cNvPr id="18" name=""/>
+          <p:cNvPr id="26" name=""/>
           <p:cNvCxnSpPr/>
           <p:nvPr/>
         </p:nvCxnSpPr>
@@ -4468,6 +4510,7 @@
           <a:lstStyle xmlns:a="http://schemas.openxmlformats.org/drawingml/2006/main"/>
           <a:p xmlns:a="http://schemas.openxmlformats.org/drawingml/2006/main">
             <a:pPr algn="l">
+              <a:buNone/>
               <a:defRPr sz="1050" b="0">
                 <a:solidFill>
                   <a:srgbClr val="606770"/>
@@ -4513,6 +4556,7 @@
           <a:lstStyle xmlns:a="http://schemas.openxmlformats.org/drawingml/2006/main"/>
           <a:p xmlns:a="http://schemas.openxmlformats.org/drawingml/2006/main">
             <a:pPr algn="r">
+              <a:buNone/>
               <a:defRPr sz="1050" b="0">
                 <a:solidFill>
                   <a:srgbClr val="606770"/>
@@ -4558,6 +4602,7 @@
           <a:lstStyle xmlns:a="http://schemas.openxmlformats.org/drawingml/2006/main"/>
           <a:p xmlns:a="http://schemas.openxmlformats.org/drawingml/2006/main">
             <a:pPr algn="l">
+              <a:buNone/>
               <a:defRPr sz="1200" b="1">
                 <a:solidFill>
                   <a:srgbClr val="2F6BFF"/>
@@ -4603,6 +4648,7 @@
           <a:lstStyle xmlns:a="http://schemas.openxmlformats.org/drawingml/2006/main"/>
           <a:p xmlns:a="http://schemas.openxmlformats.org/drawingml/2006/main">
             <a:pPr algn="l">
+              <a:buNone/>
               <a:defRPr sz="2025" b="1">
                 <a:solidFill>
                   <a:srgbClr val="15171A"/>
@@ -4648,6 +4694,7 @@
           <a:lstStyle xmlns:a="http://schemas.openxmlformats.org/drawingml/2006/main"/>
           <a:p xmlns:a="http://schemas.openxmlformats.org/drawingml/2006/main">
             <a:pPr algn="l">
+              <a:buNone/>
               <a:defRPr sz="1650" b="0">
                 <a:solidFill>
                   <a:srgbClr val="15171A"/>
@@ -4693,6 +4740,7 @@
           <a:lstStyle xmlns:a="http://schemas.openxmlformats.org/drawingml/2006/main"/>
           <a:p xmlns:a="http://schemas.openxmlformats.org/drawingml/2006/main">
             <a:pPr algn="l">
+              <a:buNone/>
               <a:defRPr sz="1650" b="0">
                 <a:solidFill>
                   <a:srgbClr val="15171A"/>
@@ -4738,6 +4786,7 @@
           <a:lstStyle xmlns:a="http://schemas.openxmlformats.org/drawingml/2006/main"/>
           <a:p xmlns:a="http://schemas.openxmlformats.org/drawingml/2006/main">
             <a:pPr algn="l">
+              <a:buNone/>
               <a:defRPr sz="1650" b="0">
                 <a:solidFill>
                   <a:srgbClr val="15171A"/>
@@ -4783,6 +4832,7 @@
           <a:lstStyle xmlns:a="http://schemas.openxmlformats.org/drawingml/2006/main"/>
           <a:p xmlns:a="http://schemas.openxmlformats.org/drawingml/2006/main">
             <a:pPr algn="l">
+              <a:buNone/>
               <a:defRPr sz="1650" b="0">
                 <a:solidFill>
                   <a:srgbClr val="15171A"/>
@@ -4828,6 +4878,7 @@
           <a:lstStyle xmlns:a="http://schemas.openxmlformats.org/drawingml/2006/main"/>
           <a:p xmlns:a="http://schemas.openxmlformats.org/drawingml/2006/main">
             <a:pPr algn="l">
+              <a:buNone/>
               <a:defRPr sz="1650" b="0">
                 <a:solidFill>
                   <a:srgbClr val="15171A"/>
@@ -4908,6 +4959,7 @@
           <a:lstStyle xmlns:a="http://schemas.openxmlformats.org/drawingml/2006/main"/>
           <a:p xmlns:a="http://schemas.openxmlformats.org/drawingml/2006/main">
             <a:pPr algn="l">
+              <a:buNone/>
               <a:defRPr sz="1275" b="0">
                 <a:solidFill>
                   <a:srgbClr val="606770"/>
@@ -4925,14 +4977,14 @@
       </p:sp>
       <p:pic>
         <p:nvPicPr>
-          <p:cNvPr id="30" name=""/>
+          <p:cNvPr id="38" name=""/>
           <p:cNvPicPr>
             <a:picLocks xmlns:a="http://schemas.openxmlformats.org/drawingml/2006/main" noChangeAspect="1"/>
           </p:cNvPicPr>
           <p:nvPr/>
         </p:nvPicPr>
         <p:blipFill>
-          <a:blip xmlns:r="http://schemas.openxmlformats.org/officeDocument/2006/relationships" xmlns:a="http://schemas.openxmlformats.org/drawingml/2006/main" r:embed="R799d7913e15a46ec"/>
+          <a:blip xmlns:r="http://schemas.openxmlformats.org/officeDocument/2006/relationships" xmlns:a="http://schemas.openxmlformats.org/drawingml/2006/main" r:embed="Ra6161c52832c4759"/>
           <a:stretch xmlns:a="http://schemas.openxmlformats.org/drawingml/2006/main"/>
         </p:blipFill>
         <p:spPr>
@@ -5006,6 +5058,7 @@
           <a:lstStyle xmlns:a="http://schemas.openxmlformats.org/drawingml/2006/main"/>
           <a:p xmlns:a="http://schemas.openxmlformats.org/drawingml/2006/main">
             <a:pPr algn="l">
+              <a:buNone/>
               <a:defRPr sz="1125" b="1">
                 <a:solidFill>
                   <a:srgbClr val="606770"/>
@@ -5051,6 +5104,7 @@
           <a:lstStyle xmlns:a="http://schemas.openxmlformats.org/drawingml/2006/main"/>
           <a:p xmlns:a="http://schemas.openxmlformats.org/drawingml/2006/main">
             <a:pPr algn="l">
+              <a:buNone/>
               <a:defRPr sz="3600" b="1">
                 <a:solidFill>
                   <a:srgbClr val="15171A"/>
@@ -5068,7 +5122,7 @@
       </p:sp>
       <p:cxnSp>
         <p:nvCxnSpPr>
-          <p:cNvPr id="36" name=""/>
+          <p:cNvPr id="50" name=""/>
           <p:cNvCxnSpPr/>
           <p:nvPr/>
         </p:nvCxnSpPr>
@@ -5118,6 +5172,7 @@
           <a:lstStyle xmlns:a="http://schemas.openxmlformats.org/drawingml/2006/main"/>
           <a:p xmlns:a="http://schemas.openxmlformats.org/drawingml/2006/main">
             <a:pPr algn="l">
+              <a:buNone/>
               <a:defRPr sz="1050" b="0">
                 <a:solidFill>
                   <a:srgbClr val="606770"/>
@@ -5163,6 +5218,7 @@
           <a:lstStyle xmlns:a="http://schemas.openxmlformats.org/drawingml/2006/main"/>
           <a:p xmlns:a="http://schemas.openxmlformats.org/drawingml/2006/main">
             <a:pPr algn="r">
+              <a:buNone/>
               <a:defRPr sz="1050" b="0">
                 <a:solidFill>
                   <a:srgbClr val="606770"/>
@@ -5208,6 +5264,7 @@
           <a:lstStyle xmlns:a="http://schemas.openxmlformats.org/drawingml/2006/main"/>
           <a:p xmlns:a="http://schemas.openxmlformats.org/drawingml/2006/main">
             <a:pPr algn="l">
+              <a:buNone/>
               <a:defRPr sz="2175" b="1">
                 <a:solidFill>
                   <a:srgbClr val="2F6BFF"/>
@@ -5253,6 +5310,7 @@
           <a:lstStyle xmlns:a="http://schemas.openxmlformats.org/drawingml/2006/main"/>
           <a:p xmlns:a="http://schemas.openxmlformats.org/drawingml/2006/main">
             <a:pPr algn="l">
+              <a:buNone/>
               <a:defRPr sz="1350" b="0">
                 <a:solidFill>
                   <a:srgbClr val="606770"/>
@@ -5298,6 +5356,7 @@
           <a:lstStyle xmlns:a="http://schemas.openxmlformats.org/drawingml/2006/main"/>
           <a:p xmlns:a="http://schemas.openxmlformats.org/drawingml/2006/main">
             <a:pPr algn="l">
+              <a:buNone/>
               <a:defRPr sz="2175" b="1">
                 <a:solidFill>
                   <a:srgbClr val="2F6BFF"/>
@@ -5343,6 +5402,7 @@
           <a:lstStyle xmlns:a="http://schemas.openxmlformats.org/drawingml/2006/main"/>
           <a:p xmlns:a="http://schemas.openxmlformats.org/drawingml/2006/main">
             <a:pPr algn="l">
+              <a:buNone/>
               <a:defRPr sz="1350" b="0">
                 <a:solidFill>
                   <a:srgbClr val="606770"/>
@@ -5388,6 +5448,7 @@
           <a:lstStyle xmlns:a="http://schemas.openxmlformats.org/drawingml/2006/main"/>
           <a:p xmlns:a="http://schemas.openxmlformats.org/drawingml/2006/main">
             <a:pPr algn="l">
+              <a:buNone/>
               <a:defRPr sz="2175" b="1">
                 <a:solidFill>
                   <a:srgbClr val="2F6BFF"/>
@@ -5433,6 +5494,7 @@
           <a:lstStyle xmlns:a="http://schemas.openxmlformats.org/drawingml/2006/main"/>
           <a:p xmlns:a="http://schemas.openxmlformats.org/drawingml/2006/main">
             <a:pPr algn="l">
+              <a:buNone/>
               <a:defRPr sz="1350" b="0">
                 <a:solidFill>
                   <a:srgbClr val="606770"/>
@@ -5478,6 +5540,7 @@
           <a:lstStyle xmlns:a="http://schemas.openxmlformats.org/drawingml/2006/main"/>
           <a:p xmlns:a="http://schemas.openxmlformats.org/drawingml/2006/main">
             <a:pPr algn="l">
+              <a:buNone/>
               <a:defRPr sz="2175" b="1">
                 <a:solidFill>
                   <a:srgbClr val="EB5A5A"/>
@@ -5523,6 +5586,7 @@
           <a:lstStyle xmlns:a="http://schemas.openxmlformats.org/drawingml/2006/main"/>
           <a:p xmlns:a="http://schemas.openxmlformats.org/drawingml/2006/main">
             <a:pPr algn="l">
+              <a:buNone/>
               <a:defRPr sz="1350" b="0">
                 <a:solidFill>
                   <a:srgbClr val="606770"/>
@@ -5603,6 +5667,7 @@
           <a:lstStyle xmlns:a="http://schemas.openxmlformats.org/drawingml/2006/main"/>
           <a:p xmlns:a="http://schemas.openxmlformats.org/drawingml/2006/main">
             <a:pPr algn="l">
+              <a:buNone/>
               <a:defRPr sz="1350" b="1">
                 <a:solidFill>
                   <a:srgbClr val="15171A"/>
@@ -5648,6 +5713,7 @@
           <a:lstStyle xmlns:a="http://schemas.openxmlformats.org/drawingml/2006/main"/>
           <a:p xmlns:a="http://schemas.openxmlformats.org/drawingml/2006/main">
             <a:pPr algn="l">
+              <a:buNone/>
               <a:defRPr sz="1125" b="0">
                 <a:solidFill>
                   <a:srgbClr val="606770"/>
@@ -5728,6 +5794,7 @@
           <a:lstStyle xmlns:a="http://schemas.openxmlformats.org/drawingml/2006/main"/>
           <a:p xmlns:a="http://schemas.openxmlformats.org/drawingml/2006/main">
             <a:pPr algn="l">
+              <a:buNone/>
               <a:defRPr sz="1350" b="1">
                 <a:solidFill>
                   <a:srgbClr val="15171A"/>
@@ -5773,6 +5840,7 @@
           <a:lstStyle xmlns:a="http://schemas.openxmlformats.org/drawingml/2006/main"/>
           <a:p xmlns:a="http://schemas.openxmlformats.org/drawingml/2006/main">
             <a:pPr algn="l">
+              <a:buNone/>
               <a:defRPr sz="1125" b="0">
                 <a:solidFill>
                   <a:srgbClr val="606770"/>
@@ -5853,6 +5921,7 @@
           <a:lstStyle xmlns:a="http://schemas.openxmlformats.org/drawingml/2006/main"/>
           <a:p xmlns:a="http://schemas.openxmlformats.org/drawingml/2006/main">
             <a:pPr algn="l">
+              <a:buNone/>
               <a:defRPr sz="1350" b="1">
                 <a:solidFill>
                   <a:srgbClr val="15171A"/>
@@ -5898,6 +5967,7 @@
           <a:lstStyle xmlns:a="http://schemas.openxmlformats.org/drawingml/2006/main"/>
           <a:p xmlns:a="http://schemas.openxmlformats.org/drawingml/2006/main">
             <a:pPr algn="l">
+              <a:buNone/>
               <a:defRPr sz="1125" b="0">
                 <a:solidFill>
                   <a:srgbClr val="606770"/>
@@ -5978,6 +6048,7 @@
           <a:lstStyle xmlns:a="http://schemas.openxmlformats.org/drawingml/2006/main"/>
           <a:p xmlns:a="http://schemas.openxmlformats.org/drawingml/2006/main">
             <a:pPr algn="l">
+              <a:buNone/>
               <a:defRPr sz="1350" b="1">
                 <a:solidFill>
                   <a:srgbClr val="15171A"/>
@@ -6023,6 +6094,7 @@
           <a:lstStyle xmlns:a="http://schemas.openxmlformats.org/drawingml/2006/main"/>
           <a:p xmlns:a="http://schemas.openxmlformats.org/drawingml/2006/main">
             <a:pPr algn="l">
+              <a:buNone/>
               <a:defRPr sz="1125" b="0">
                 <a:solidFill>
                   <a:srgbClr val="606770"/>
@@ -6103,6 +6175,7 @@
           <a:lstStyle xmlns:a="http://schemas.openxmlformats.org/drawingml/2006/main"/>
           <a:p xmlns:a="http://schemas.openxmlformats.org/drawingml/2006/main">
             <a:pPr algn="l">
+              <a:buNone/>
               <a:defRPr sz="1275" b="1">
                 <a:solidFill>
                   <a:srgbClr val="EB5A5A"/>
@@ -6148,6 +6221,7 @@
           <a:lstStyle xmlns:a="http://schemas.openxmlformats.org/drawingml/2006/main"/>
           <a:p xmlns:a="http://schemas.openxmlformats.org/drawingml/2006/main">
             <a:pPr algn="l">
+              <a:buNone/>
               <a:defRPr sz="1275" b="0">
                 <a:solidFill>
                   <a:srgbClr val="DCE0E5"/>
@@ -6193,6 +6267,7 @@
           <a:lstStyle xmlns:a="http://schemas.openxmlformats.org/drawingml/2006/main"/>
           <a:p xmlns:a="http://schemas.openxmlformats.org/drawingml/2006/main">
             <a:pPr algn="r">
+              <a:buNone/>
               <a:defRPr sz="1275" b="0">
                 <a:solidFill>
                   <a:srgbClr val="DCE0E5"/>
@@ -6210,14 +6285,14 @@
       </p:sp>
       <p:pic>
         <p:nvPicPr>
-          <p:cNvPr id="63" name=""/>
+          <p:cNvPr id="77" name=""/>
           <p:cNvPicPr>
             <a:picLocks xmlns:a="http://schemas.openxmlformats.org/drawingml/2006/main" noChangeAspect="1"/>
           </p:cNvPicPr>
           <p:nvPr/>
         </p:nvPicPr>
         <p:blipFill>
-          <a:blip xmlns:r="http://schemas.openxmlformats.org/officeDocument/2006/relationships" xmlns:a="http://schemas.openxmlformats.org/drawingml/2006/main" r:embed="R552c9d3b28634381"/>
+          <a:blip xmlns:r="http://schemas.openxmlformats.org/officeDocument/2006/relationships" xmlns:a="http://schemas.openxmlformats.org/drawingml/2006/main" r:embed="R178827c61c8548c7"/>
           <a:srcRect xmlns:a="http://schemas.openxmlformats.org/drawingml/2006/main" l="0" t="0" r="0" b="0"/>
           <a:stretch xmlns:a="http://schemas.openxmlformats.org/drawingml/2006/main">
             <a:fillRect l="0" t="0" r="0" b="0"/>
@@ -6237,14 +6312,14 @@
       </p:pic>
       <p:pic>
         <p:nvPicPr>
-          <p:cNvPr id="64" name=""/>
+          <p:cNvPr id="78" name=""/>
           <p:cNvPicPr>
             <a:picLocks xmlns:a="http://schemas.openxmlformats.org/drawingml/2006/main" noChangeAspect="1"/>
           </p:cNvPicPr>
           <p:nvPr/>
         </p:nvPicPr>
         <p:blipFill>
-          <a:blip xmlns:r="http://schemas.openxmlformats.org/officeDocument/2006/relationships" xmlns:a="http://schemas.openxmlformats.org/drawingml/2006/main" r:embed="R49845ebf32974fb0"/>
+          <a:blip xmlns:r="http://schemas.openxmlformats.org/officeDocument/2006/relationships" xmlns:a="http://schemas.openxmlformats.org/drawingml/2006/main" r:embed="Ra82bc8af7b8140fd"/>
           <a:srcRect xmlns:a="http://schemas.openxmlformats.org/drawingml/2006/main" l="0" t="0" r="0" b="0"/>
           <a:stretch xmlns:a="http://schemas.openxmlformats.org/drawingml/2006/main">
             <a:fillRect l="0" t="0" r="0" b="0"/>
@@ -6264,14 +6339,14 @@
       </p:pic>
       <p:pic>
         <p:nvPicPr>
-          <p:cNvPr id="65" name=""/>
+          <p:cNvPr id="79" name=""/>
           <p:cNvPicPr>
             <a:picLocks xmlns:a="http://schemas.openxmlformats.org/drawingml/2006/main" noChangeAspect="1"/>
           </p:cNvPicPr>
           <p:nvPr/>
         </p:nvPicPr>
         <p:blipFill>
-          <a:blip xmlns:r="http://schemas.openxmlformats.org/officeDocument/2006/relationships" xmlns:a="http://schemas.openxmlformats.org/drawingml/2006/main" r:embed="Rd948d9e1d61f4cd2"/>
+          <a:blip xmlns:r="http://schemas.openxmlformats.org/officeDocument/2006/relationships" xmlns:a="http://schemas.openxmlformats.org/drawingml/2006/main" r:embed="R1270ba78bb8a4e4b"/>
           <a:srcRect xmlns:a="http://schemas.openxmlformats.org/drawingml/2006/main" l="0" t="0" r="0" b="0"/>
           <a:stretch xmlns:a="http://schemas.openxmlformats.org/drawingml/2006/main">
             <a:fillRect l="0" t="0" r="0" b="0"/>
@@ -6291,14 +6366,14 @@
       </p:pic>
       <p:pic>
         <p:nvPicPr>
-          <p:cNvPr id="66" name=""/>
+          <p:cNvPr id="80" name=""/>
           <p:cNvPicPr>
             <a:picLocks xmlns:a="http://schemas.openxmlformats.org/drawingml/2006/main" noChangeAspect="1"/>
           </p:cNvPicPr>
           <p:nvPr/>
         </p:nvPicPr>
         <p:blipFill>
-          <a:blip xmlns:r="http://schemas.openxmlformats.org/officeDocument/2006/relationships" xmlns:a="http://schemas.openxmlformats.org/drawingml/2006/main" r:embed="Re0d471ff7cbb4f85"/>
+          <a:blip xmlns:r="http://schemas.openxmlformats.org/officeDocument/2006/relationships" xmlns:a="http://schemas.openxmlformats.org/drawingml/2006/main" r:embed="R13229acdc0184f70"/>
           <a:srcRect xmlns:a="http://schemas.openxmlformats.org/drawingml/2006/main" l="0" t="0" r="0" b="0"/>
           <a:stretch xmlns:a="http://schemas.openxmlformats.org/drawingml/2006/main">
             <a:fillRect l="0" t="0" r="0" b="0"/>
@@ -6375,6 +6450,7 @@
           <a:lstStyle xmlns:a="http://schemas.openxmlformats.org/drawingml/2006/main"/>
           <a:p xmlns:a="http://schemas.openxmlformats.org/drawingml/2006/main">
             <a:pPr algn="l">
+              <a:buNone/>
               <a:defRPr sz="1125" b="1">
                 <a:solidFill>
                   <a:srgbClr val="606770"/>
@@ -6420,6 +6496,7 @@
           <a:lstStyle xmlns:a="http://schemas.openxmlformats.org/drawingml/2006/main"/>
           <a:p xmlns:a="http://schemas.openxmlformats.org/drawingml/2006/main">
             <a:pPr algn="l">
+              <a:buNone/>
               <a:defRPr sz="3600" b="1">
                 <a:solidFill>
                   <a:srgbClr val="15171A"/>
@@ -6437,7 +6514,7 @@
       </p:sp>
       <p:cxnSp>
         <p:nvCxnSpPr>
-          <p:cNvPr id="30" name=""/>
+          <p:cNvPr id="36" name=""/>
           <p:cNvCxnSpPr/>
           <p:nvPr/>
         </p:nvCxnSpPr>
@@ -6487,6 +6564,7 @@
           <a:lstStyle xmlns:a="http://schemas.openxmlformats.org/drawingml/2006/main"/>
           <a:p xmlns:a="http://schemas.openxmlformats.org/drawingml/2006/main">
             <a:pPr algn="l">
+              <a:buNone/>
               <a:defRPr sz="1050" b="0">
                 <a:solidFill>
                   <a:srgbClr val="606770"/>
@@ -6532,6 +6610,7 @@
           <a:lstStyle xmlns:a="http://schemas.openxmlformats.org/drawingml/2006/main"/>
           <a:p xmlns:a="http://schemas.openxmlformats.org/drawingml/2006/main">
             <a:pPr algn="r">
+              <a:buNone/>
               <a:defRPr sz="1050" b="0">
                 <a:solidFill>
                   <a:srgbClr val="606770"/>
@@ -6577,6 +6656,7 @@
           <a:lstStyle xmlns:a="http://schemas.openxmlformats.org/drawingml/2006/main"/>
           <a:p xmlns:a="http://schemas.openxmlformats.org/drawingml/2006/main">
             <a:pPr algn="l">
+              <a:buNone/>
               <a:defRPr sz="2550" b="1">
                 <a:solidFill>
                   <a:srgbClr val="15171A"/>
@@ -6622,6 +6702,7 @@
           <a:lstStyle xmlns:a="http://schemas.openxmlformats.org/drawingml/2006/main"/>
           <a:p xmlns:a="http://schemas.openxmlformats.org/drawingml/2006/main">
             <a:pPr algn="l">
+              <a:buNone/>
               <a:defRPr sz="1350" b="0">
                 <a:solidFill>
                   <a:srgbClr val="606770"/>
@@ -6667,6 +6748,7 @@
           <a:lstStyle xmlns:a="http://schemas.openxmlformats.org/drawingml/2006/main"/>
           <a:p xmlns:a="http://schemas.openxmlformats.org/drawingml/2006/main">
             <a:pPr algn="l">
+              <a:buNone/>
               <a:defRPr sz="2550" b="1">
                 <a:solidFill>
                   <a:srgbClr val="15171A"/>
@@ -6712,6 +6794,7 @@
           <a:lstStyle xmlns:a="http://schemas.openxmlformats.org/drawingml/2006/main"/>
           <a:p xmlns:a="http://schemas.openxmlformats.org/drawingml/2006/main">
             <a:pPr algn="l">
+              <a:buNone/>
               <a:defRPr sz="1350" b="0">
                 <a:solidFill>
                   <a:srgbClr val="606770"/>
@@ -6757,6 +6840,7 @@
           <a:lstStyle xmlns:a="http://schemas.openxmlformats.org/drawingml/2006/main"/>
           <a:p xmlns:a="http://schemas.openxmlformats.org/drawingml/2006/main">
             <a:pPr algn="l">
+              <a:buNone/>
               <a:defRPr sz="2550" b="1">
                 <a:solidFill>
                   <a:srgbClr val="15171A"/>
@@ -6802,6 +6886,7 @@
           <a:lstStyle xmlns:a="http://schemas.openxmlformats.org/drawingml/2006/main"/>
           <a:p xmlns:a="http://schemas.openxmlformats.org/drawingml/2006/main">
             <a:pPr algn="l">
+              <a:buNone/>
               <a:defRPr sz="1350" b="0">
                 <a:solidFill>
                   <a:srgbClr val="606770"/>
@@ -6979,6 +7064,7 @@
           <a:lstStyle xmlns:a="http://schemas.openxmlformats.org/drawingml/2006/main"/>
           <a:p xmlns:a="http://schemas.openxmlformats.org/drawingml/2006/main">
             <a:pPr algn="l">
+              <a:buNone/>
               <a:defRPr sz="2025" b="1">
                 <a:solidFill>
                   <a:srgbClr val="15171A"/>
@@ -7024,6 +7110,7 @@
           <a:lstStyle xmlns:a="http://schemas.openxmlformats.org/drawingml/2006/main"/>
           <a:p xmlns:a="http://schemas.openxmlformats.org/drawingml/2006/main">
             <a:pPr algn="l">
+              <a:buNone/>
               <a:defRPr sz="1650" b="0">
                 <a:solidFill>
                   <a:srgbClr val="15171A"/>
@@ -7069,6 +7156,7 @@
           <a:lstStyle xmlns:a="http://schemas.openxmlformats.org/drawingml/2006/main"/>
           <a:p xmlns:a="http://schemas.openxmlformats.org/drawingml/2006/main">
             <a:pPr algn="l">
+              <a:buNone/>
               <a:defRPr sz="1650" b="0">
                 <a:solidFill>
                   <a:srgbClr val="15171A"/>
@@ -7114,6 +7202,7 @@
           <a:lstStyle xmlns:a="http://schemas.openxmlformats.org/drawingml/2006/main"/>
           <a:p xmlns:a="http://schemas.openxmlformats.org/drawingml/2006/main">
             <a:pPr algn="l">
+              <a:buNone/>
               <a:defRPr sz="1650" b="0">
                 <a:solidFill>
                   <a:srgbClr val="15171A"/>
@@ -7159,6 +7248,7 @@
           <a:lstStyle xmlns:a="http://schemas.openxmlformats.org/drawingml/2006/main"/>
           <a:p xmlns:a="http://schemas.openxmlformats.org/drawingml/2006/main">
             <a:pPr algn="l">
+              <a:buNone/>
               <a:defRPr sz="2025" b="1">
                 <a:solidFill>
                   <a:srgbClr val="15171A"/>
@@ -7235,6 +7325,7 @@
           <a:lstStyle xmlns:a="http://schemas.openxmlformats.org/drawingml/2006/main"/>
           <a:p xmlns:a="http://schemas.openxmlformats.org/drawingml/2006/main">
             <a:pPr algn="l">
+              <a:buNone/>
               <a:defRPr sz="1425" b="0">
                 <a:solidFill>
                   <a:srgbClr val="15171A"/>
@@ -7311,6 +7402,7 @@
           <a:lstStyle xmlns:a="http://schemas.openxmlformats.org/drawingml/2006/main"/>
           <a:p xmlns:a="http://schemas.openxmlformats.org/drawingml/2006/main">
             <a:pPr algn="l">
+              <a:buNone/>
               <a:defRPr sz="1425" b="0">
                 <a:solidFill>
                   <a:srgbClr val="15171A"/>
@@ -7387,6 +7479,7 @@
           <a:lstStyle xmlns:a="http://schemas.openxmlformats.org/drawingml/2006/main"/>
           <a:p xmlns:a="http://schemas.openxmlformats.org/drawingml/2006/main">
             <a:pPr algn="l">
+              <a:buNone/>
               <a:defRPr sz="1425" b="0">
                 <a:solidFill>
                   <a:srgbClr val="15171A"/>
@@ -7432,6 +7525,7 @@
           <a:lstStyle xmlns:a="http://schemas.openxmlformats.org/drawingml/2006/main"/>
           <a:p xmlns:a="http://schemas.openxmlformats.org/drawingml/2006/main">
             <a:pPr algn="l">
+              <a:buNone/>
               <a:defRPr sz="1350" b="0">
                 <a:solidFill>
                   <a:srgbClr val="606770"/>
@@ -7506,6 +7600,7 @@
           <a:lstStyle xmlns:a="http://schemas.openxmlformats.org/drawingml/2006/main"/>
           <a:p xmlns:a="http://schemas.openxmlformats.org/drawingml/2006/main">
             <a:pPr algn="l">
+              <a:buNone/>
               <a:defRPr sz="1125" b="1">
                 <a:solidFill>
                   <a:srgbClr val="606770"/>
@@ -7551,6 +7646,7 @@
           <a:lstStyle xmlns:a="http://schemas.openxmlformats.org/drawingml/2006/main"/>
           <a:p xmlns:a="http://schemas.openxmlformats.org/drawingml/2006/main">
             <a:pPr algn="l">
+              <a:buNone/>
               <a:defRPr sz="3600" b="1">
                 <a:solidFill>
                   <a:srgbClr val="15171A"/>
@@ -7568,7 +7664,7 @@
       </p:sp>
       <p:cxnSp>
         <p:nvCxnSpPr>
-          <p:cNvPr id="36" name=""/>
+          <p:cNvPr id="48" name=""/>
           <p:cNvCxnSpPr/>
           <p:nvPr/>
         </p:nvCxnSpPr>
@@ -7618,6 +7714,7 @@
           <a:lstStyle xmlns:a="http://schemas.openxmlformats.org/drawingml/2006/main"/>
           <a:p xmlns:a="http://schemas.openxmlformats.org/drawingml/2006/main">
             <a:pPr algn="l">
+              <a:buNone/>
               <a:defRPr sz="1050" b="0">
                 <a:solidFill>
                   <a:srgbClr val="606770"/>
@@ -7663,6 +7760,7 @@
           <a:lstStyle xmlns:a="http://schemas.openxmlformats.org/drawingml/2006/main"/>
           <a:p xmlns:a="http://schemas.openxmlformats.org/drawingml/2006/main">
             <a:pPr algn="r">
+              <a:buNone/>
               <a:defRPr sz="1050" b="0">
                 <a:solidFill>
                   <a:srgbClr val="606770"/>
@@ -7680,7 +7778,7 @@
       </p:sp>
       <p:cxnSp>
         <p:nvCxnSpPr>
-          <p:cNvPr id="39" name=""/>
+          <p:cNvPr id="51" name=""/>
           <p:cNvCxnSpPr/>
           <p:nvPr/>
         </p:nvCxnSpPr>
@@ -7796,6 +7894,7 @@
           <a:lstStyle xmlns:a="http://schemas.openxmlformats.org/drawingml/2006/main"/>
           <a:p xmlns:a="http://schemas.openxmlformats.org/drawingml/2006/main">
             <a:pPr algn="l">
+              <a:buNone/>
               <a:defRPr sz="1875" b="1">
                 <a:solidFill>
                   <a:srgbClr val="15171A"/>
@@ -7841,6 +7940,7 @@
           <a:lstStyle xmlns:a="http://schemas.openxmlformats.org/drawingml/2006/main"/>
           <a:p xmlns:a="http://schemas.openxmlformats.org/drawingml/2006/main">
             <a:pPr algn="l">
+              <a:buNone/>
               <a:defRPr sz="1350" b="0">
                 <a:solidFill>
                   <a:srgbClr val="606770"/>
@@ -7952,6 +8052,7 @@
           <a:lstStyle xmlns:a="http://schemas.openxmlformats.org/drawingml/2006/main"/>
           <a:p xmlns:a="http://schemas.openxmlformats.org/drawingml/2006/main">
             <a:pPr algn="l">
+              <a:buNone/>
               <a:defRPr sz="1875" b="1">
                 <a:solidFill>
                   <a:srgbClr val="15171A"/>
@@ -7997,6 +8098,7 @@
           <a:lstStyle xmlns:a="http://schemas.openxmlformats.org/drawingml/2006/main"/>
           <a:p xmlns:a="http://schemas.openxmlformats.org/drawingml/2006/main">
             <a:pPr algn="l">
+              <a:buNone/>
               <a:defRPr sz="1350" b="0">
                 <a:solidFill>
                   <a:srgbClr val="606770"/>
@@ -8108,6 +8210,7 @@
           <a:lstStyle xmlns:a="http://schemas.openxmlformats.org/drawingml/2006/main"/>
           <a:p xmlns:a="http://schemas.openxmlformats.org/drawingml/2006/main">
             <a:pPr algn="l">
+              <a:buNone/>
               <a:defRPr sz="1875" b="1">
                 <a:solidFill>
                   <a:srgbClr val="15171A"/>
@@ -8153,6 +8256,7 @@
           <a:lstStyle xmlns:a="http://schemas.openxmlformats.org/drawingml/2006/main"/>
           <a:p xmlns:a="http://schemas.openxmlformats.org/drawingml/2006/main">
             <a:pPr algn="l">
+              <a:buNone/>
               <a:defRPr sz="1350" b="0">
                 <a:solidFill>
                   <a:srgbClr val="606770"/>
@@ -8264,6 +8368,7 @@
           <a:lstStyle xmlns:a="http://schemas.openxmlformats.org/drawingml/2006/main"/>
           <a:p xmlns:a="http://schemas.openxmlformats.org/drawingml/2006/main">
             <a:pPr algn="l">
+              <a:buNone/>
               <a:defRPr sz="1875" b="1">
                 <a:solidFill>
                   <a:srgbClr val="15171A"/>
@@ -8309,6 +8414,7 @@
           <a:lstStyle xmlns:a="http://schemas.openxmlformats.org/drawingml/2006/main"/>
           <a:p xmlns:a="http://schemas.openxmlformats.org/drawingml/2006/main">
             <a:pPr algn="l">
+              <a:buNone/>
               <a:defRPr sz="1350" b="0">
                 <a:solidFill>
                   <a:srgbClr val="606770"/>
@@ -8424,6 +8530,7 @@
           <a:lstStyle xmlns:a="http://schemas.openxmlformats.org/drawingml/2006/main"/>
           <a:p xmlns:a="http://schemas.openxmlformats.org/drawingml/2006/main">
             <a:pPr algn="l">
+              <a:buNone/>
               <a:defRPr sz="1950" b="1">
                 <a:solidFill>
                   <a:srgbClr val="15171A"/>
@@ -8500,6 +8607,7 @@
           <a:lstStyle xmlns:a="http://schemas.openxmlformats.org/drawingml/2006/main"/>
           <a:p xmlns:a="http://schemas.openxmlformats.org/drawingml/2006/main">
             <a:pPr algn="l">
+              <a:buNone/>
               <a:defRPr sz="1425" b="0">
                 <a:solidFill>
                   <a:srgbClr val="15171A"/>
@@ -8576,6 +8684,7 @@
           <a:lstStyle xmlns:a="http://schemas.openxmlformats.org/drawingml/2006/main"/>
           <a:p xmlns:a="http://schemas.openxmlformats.org/drawingml/2006/main">
             <a:pPr algn="l">
+              <a:buNone/>
               <a:defRPr sz="1425" b="0">
                 <a:solidFill>
                   <a:srgbClr val="15171A"/>
@@ -8652,6 +8761,7 @@
           <a:lstStyle xmlns:a="http://schemas.openxmlformats.org/drawingml/2006/main"/>
           <a:p xmlns:a="http://schemas.openxmlformats.org/drawingml/2006/main">
             <a:pPr algn="l">
+              <a:buNone/>
               <a:defRPr sz="1425" b="0">
                 <a:solidFill>
                   <a:srgbClr val="15171A"/>
@@ -8697,6 +8807,7 @@
           <a:lstStyle xmlns:a="http://schemas.openxmlformats.org/drawingml/2006/main"/>
           <a:p xmlns:a="http://schemas.openxmlformats.org/drawingml/2006/main">
             <a:pPr algn="l">
+              <a:buNone/>
               <a:defRPr sz="1950" b="1">
                 <a:solidFill>
                   <a:srgbClr val="FFFFFF"/>
@@ -8742,6 +8853,7 @@
           <a:lstStyle xmlns:a="http://schemas.openxmlformats.org/drawingml/2006/main"/>
           <a:p xmlns:a="http://schemas.openxmlformats.org/drawingml/2006/main">
             <a:pPr algn="l">
+              <a:buNone/>
               <a:defRPr sz="1500" b="0">
                 <a:solidFill>
                   <a:srgbClr val="DCE0E5"/>
@@ -8816,6 +8928,7 @@
           <a:lstStyle xmlns:a="http://schemas.openxmlformats.org/drawingml/2006/main"/>
           <a:p xmlns:a="http://schemas.openxmlformats.org/drawingml/2006/main">
             <a:pPr algn="l">
+              <a:buNone/>
               <a:defRPr sz="1125" b="1">
                 <a:solidFill>
                   <a:srgbClr val="606770"/>
@@ -8861,6 +8974,7 @@
           <a:lstStyle xmlns:a="http://schemas.openxmlformats.org/drawingml/2006/main"/>
           <a:p xmlns:a="http://schemas.openxmlformats.org/drawingml/2006/main">
             <a:pPr algn="l">
+              <a:buNone/>
               <a:defRPr sz="3600" b="1">
                 <a:solidFill>
                   <a:srgbClr val="15171A"/>
@@ -8878,7 +8992,7 @@
       </p:sp>
       <p:cxnSp>
         <p:nvCxnSpPr>
-          <p:cNvPr id="45" name=""/>
+          <p:cNvPr id="51" name=""/>
           <p:cNvCxnSpPr/>
           <p:nvPr/>
         </p:nvCxnSpPr>
@@ -8928,6 +9042,7 @@
           <a:lstStyle xmlns:a="http://schemas.openxmlformats.org/drawingml/2006/main"/>
           <a:p xmlns:a="http://schemas.openxmlformats.org/drawingml/2006/main">
             <a:pPr algn="l">
+              <a:buNone/>
               <a:defRPr sz="1050" b="0">
                 <a:solidFill>
                   <a:srgbClr val="606770"/>
@@ -8973,6 +9088,7 @@
           <a:lstStyle xmlns:a="http://schemas.openxmlformats.org/drawingml/2006/main"/>
           <a:p xmlns:a="http://schemas.openxmlformats.org/drawingml/2006/main">
             <a:pPr algn="r">
+              <a:buNone/>
               <a:defRPr sz="1050" b="0">
                 <a:solidFill>
                   <a:srgbClr val="606770"/>
@@ -9018,6 +9134,7 @@
           <a:lstStyle xmlns:a="http://schemas.openxmlformats.org/drawingml/2006/main"/>
           <a:p xmlns:a="http://schemas.openxmlformats.org/drawingml/2006/main">
             <a:pPr algn="l">
+              <a:buNone/>
               <a:defRPr sz="1350" b="1">
                 <a:solidFill>
                   <a:srgbClr val="606770"/>
@@ -9063,6 +9180,7 @@
           <a:lstStyle xmlns:a="http://schemas.openxmlformats.org/drawingml/2006/main"/>
           <a:p xmlns:a="http://schemas.openxmlformats.org/drawingml/2006/main">
             <a:pPr algn="l">
+              <a:buNone/>
               <a:defRPr sz="1350" b="1">
                 <a:solidFill>
                   <a:srgbClr val="606770"/>
@@ -9108,6 +9226,7 @@
           <a:lstStyle xmlns:a="http://schemas.openxmlformats.org/drawingml/2006/main"/>
           <a:p xmlns:a="http://schemas.openxmlformats.org/drawingml/2006/main">
             <a:pPr algn="l">
+              <a:buNone/>
               <a:defRPr sz="1350" b="1">
                 <a:solidFill>
                   <a:srgbClr val="606770"/>
@@ -9184,6 +9303,7 @@
           <a:lstStyle xmlns:a="http://schemas.openxmlformats.org/drawingml/2006/main"/>
           <a:p xmlns:a="http://schemas.openxmlformats.org/drawingml/2006/main">
             <a:pPr algn="l">
+              <a:buNone/>
               <a:defRPr sz="1500" b="1">
                 <a:solidFill>
                   <a:srgbClr val="15171A"/>
@@ -9229,6 +9349,7 @@
           <a:lstStyle xmlns:a="http://schemas.openxmlformats.org/drawingml/2006/main"/>
           <a:p xmlns:a="http://schemas.openxmlformats.org/drawingml/2006/main">
             <a:pPr algn="l">
+              <a:buNone/>
               <a:defRPr sz="1275" b="1">
                 <a:solidFill>
                   <a:srgbClr val="2F6BFF"/>
@@ -9274,6 +9395,7 @@
           <a:lstStyle xmlns:a="http://schemas.openxmlformats.org/drawingml/2006/main"/>
           <a:p xmlns:a="http://schemas.openxmlformats.org/drawingml/2006/main">
             <a:pPr algn="l">
+              <a:buNone/>
               <a:defRPr sz="1350" b="0">
                 <a:solidFill>
                   <a:srgbClr val="606770"/>
@@ -9350,6 +9472,7 @@
           <a:lstStyle xmlns:a="http://schemas.openxmlformats.org/drawingml/2006/main"/>
           <a:p xmlns:a="http://schemas.openxmlformats.org/drawingml/2006/main">
             <a:pPr algn="l">
+              <a:buNone/>
               <a:defRPr sz="1500" b="1">
                 <a:solidFill>
                   <a:srgbClr val="15171A"/>
@@ -9395,6 +9518,7 @@
           <a:lstStyle xmlns:a="http://schemas.openxmlformats.org/drawingml/2006/main"/>
           <a:p xmlns:a="http://schemas.openxmlformats.org/drawingml/2006/main">
             <a:pPr algn="l">
+              <a:buNone/>
               <a:defRPr sz="1275" b="1">
                 <a:solidFill>
                   <a:srgbClr val="2F6BFF"/>
@@ -9440,6 +9564,7 @@
           <a:lstStyle xmlns:a="http://schemas.openxmlformats.org/drawingml/2006/main"/>
           <a:p xmlns:a="http://schemas.openxmlformats.org/drawingml/2006/main">
             <a:pPr algn="l">
+              <a:buNone/>
               <a:defRPr sz="1350" b="0">
                 <a:solidFill>
                   <a:srgbClr val="606770"/>
@@ -9516,6 +9641,7 @@
           <a:lstStyle xmlns:a="http://schemas.openxmlformats.org/drawingml/2006/main"/>
           <a:p xmlns:a="http://schemas.openxmlformats.org/drawingml/2006/main">
             <a:pPr algn="l">
+              <a:buNone/>
               <a:defRPr sz="1500" b="1">
                 <a:solidFill>
                   <a:srgbClr val="15171A"/>
@@ -9561,6 +9687,7 @@
           <a:lstStyle xmlns:a="http://schemas.openxmlformats.org/drawingml/2006/main"/>
           <a:p xmlns:a="http://schemas.openxmlformats.org/drawingml/2006/main">
             <a:pPr algn="l">
+              <a:buNone/>
               <a:defRPr sz="1275" b="1">
                 <a:solidFill>
                   <a:srgbClr val="2F6BFF"/>
@@ -9606,6 +9733,7 @@
           <a:lstStyle xmlns:a="http://schemas.openxmlformats.org/drawingml/2006/main"/>
           <a:p xmlns:a="http://schemas.openxmlformats.org/drawingml/2006/main">
             <a:pPr algn="l">
+              <a:buNone/>
               <a:defRPr sz="1350" b="0">
                 <a:solidFill>
                   <a:srgbClr val="606770"/>
@@ -9682,6 +9810,7 @@
           <a:lstStyle xmlns:a="http://schemas.openxmlformats.org/drawingml/2006/main"/>
           <a:p xmlns:a="http://schemas.openxmlformats.org/drawingml/2006/main">
             <a:pPr algn="l">
+              <a:buNone/>
               <a:defRPr sz="1500" b="0">
                 <a:solidFill>
                   <a:srgbClr val="15171A"/>
@@ -9727,6 +9856,7 @@
           <a:lstStyle xmlns:a="http://schemas.openxmlformats.org/drawingml/2006/main"/>
           <a:p xmlns:a="http://schemas.openxmlformats.org/drawingml/2006/main">
             <a:pPr algn="l">
+              <a:buNone/>
               <a:defRPr sz="1275" b="1">
                 <a:solidFill>
                   <a:srgbClr val="EB5A5A"/>
@@ -9772,6 +9902,7 @@
           <a:lstStyle xmlns:a="http://schemas.openxmlformats.org/drawingml/2006/main"/>
           <a:p xmlns:a="http://schemas.openxmlformats.org/drawingml/2006/main">
             <a:pPr algn="l">
+              <a:buNone/>
               <a:defRPr sz="1350" b="0">
                 <a:solidFill>
                   <a:srgbClr val="606770"/>
@@ -9848,6 +9979,7 @@
           <a:lstStyle xmlns:a="http://schemas.openxmlformats.org/drawingml/2006/main"/>
           <a:p xmlns:a="http://schemas.openxmlformats.org/drawingml/2006/main">
             <a:pPr algn="l">
+              <a:buNone/>
               <a:defRPr sz="1500" b="0">
                 <a:solidFill>
                   <a:srgbClr val="15171A"/>
@@ -9893,6 +10025,7 @@
           <a:lstStyle xmlns:a="http://schemas.openxmlformats.org/drawingml/2006/main"/>
           <a:p xmlns:a="http://schemas.openxmlformats.org/drawingml/2006/main">
             <a:pPr algn="l">
+              <a:buNone/>
               <a:defRPr sz="1275" b="1">
                 <a:solidFill>
                   <a:srgbClr val="EB5A5A"/>
@@ -9938,6 +10071,7 @@
           <a:lstStyle xmlns:a="http://schemas.openxmlformats.org/drawingml/2006/main"/>
           <a:p xmlns:a="http://schemas.openxmlformats.org/drawingml/2006/main">
             <a:pPr algn="l">
+              <a:buNone/>
               <a:defRPr sz="1350" b="0">
                 <a:solidFill>
                   <a:srgbClr val="606770"/>
@@ -10049,6 +10183,7 @@
           <a:lstStyle xmlns:a="http://schemas.openxmlformats.org/drawingml/2006/main"/>
           <a:p xmlns:a="http://schemas.openxmlformats.org/drawingml/2006/main">
             <a:pPr algn="l">
+              <a:buNone/>
               <a:defRPr sz="1875" b="1">
                 <a:solidFill>
                   <a:srgbClr val="15171A"/>
@@ -10125,6 +10260,7 @@
           <a:lstStyle xmlns:a="http://schemas.openxmlformats.org/drawingml/2006/main"/>
           <a:p xmlns:a="http://schemas.openxmlformats.org/drawingml/2006/main">
             <a:pPr algn="l">
+              <a:buNone/>
               <a:defRPr sz="1275" b="0">
                 <a:solidFill>
                   <a:srgbClr val="15171A"/>
@@ -10201,6 +10337,7 @@
           <a:lstStyle xmlns:a="http://schemas.openxmlformats.org/drawingml/2006/main"/>
           <a:p xmlns:a="http://schemas.openxmlformats.org/drawingml/2006/main">
             <a:pPr algn="l">
+              <a:buNone/>
               <a:defRPr sz="1275" b="0">
                 <a:solidFill>
                   <a:srgbClr val="15171A"/>
@@ -10277,6 +10414,7 @@
           <a:lstStyle xmlns:a="http://schemas.openxmlformats.org/drawingml/2006/main"/>
           <a:p xmlns:a="http://schemas.openxmlformats.org/drawingml/2006/main">
             <a:pPr algn="l">
+              <a:buNone/>
               <a:defRPr sz="1275" b="0">
                 <a:solidFill>
                   <a:srgbClr val="15171A"/>
@@ -10353,6 +10491,7 @@
           <a:lstStyle xmlns:a="http://schemas.openxmlformats.org/drawingml/2006/main"/>
           <a:p xmlns:a="http://schemas.openxmlformats.org/drawingml/2006/main">
             <a:pPr algn="l">
+              <a:buNone/>
               <a:defRPr sz="1275" b="0">
                 <a:solidFill>
                   <a:srgbClr val="15171A"/>
@@ -10429,6 +10568,7 @@
           <a:lstStyle xmlns:a="http://schemas.openxmlformats.org/drawingml/2006/main"/>
           <a:p xmlns:a="http://schemas.openxmlformats.org/drawingml/2006/main">
             <a:pPr algn="l">
+              <a:buNone/>
               <a:defRPr sz="1275" b="0">
                 <a:solidFill>
                   <a:srgbClr val="15171A"/>
@@ -10474,6 +10614,7 @@
           <a:lstStyle xmlns:a="http://schemas.openxmlformats.org/drawingml/2006/main"/>
           <a:p xmlns:a="http://schemas.openxmlformats.org/drawingml/2006/main">
             <a:pPr algn="ctr">
+              <a:buNone/>
               <a:defRPr sz="1275" b="0">
                 <a:solidFill>
                   <a:srgbClr val="606770"/>
@@ -10641,6 +10782,7 @@
           <a:lstStyle xmlns:a="http://schemas.openxmlformats.org/drawingml/2006/main"/>
           <a:p xmlns:a="http://schemas.openxmlformats.org/drawingml/2006/main">
             <a:pPr algn="l">
+              <a:buNone/>
               <a:defRPr sz="4650" b="1">
                 <a:solidFill>
                   <a:srgbClr val="15171A"/>
@@ -10687,6 +10829,7 @@
           <a:lstStyle xmlns:a="http://schemas.openxmlformats.org/drawingml/2006/main"/>
           <a:p xmlns:a="http://schemas.openxmlformats.org/drawingml/2006/main">
             <a:pPr algn="l">
+              <a:buNone/>
               <a:defRPr sz="1875" b="0">
                 <a:solidFill>
                   <a:srgbClr val="606770"/>
@@ -10767,6 +10910,7 @@
           <a:lstStyle xmlns:a="http://schemas.openxmlformats.org/drawingml/2006/main"/>
           <a:p xmlns:a="http://schemas.openxmlformats.org/drawingml/2006/main">
             <a:pPr algn="l">
+              <a:buNone/>
               <a:defRPr sz="2100" b="1">
                 <a:solidFill>
                   <a:srgbClr val="FFFFFF"/>
@@ -10812,6 +10956,7 @@
           <a:lstStyle xmlns:a="http://schemas.openxmlformats.org/drawingml/2006/main"/>
           <a:p xmlns:a="http://schemas.openxmlformats.org/drawingml/2006/main">
             <a:pPr algn="r">
+              <a:buNone/>
               <a:defRPr sz="1500" b="0">
                 <a:solidFill>
                   <a:srgbClr val="DCE0E5"/>
@@ -10829,7 +10974,7 @@
       </p:sp>
       <p:cxnSp>
         <p:nvCxnSpPr>
-          <p:cNvPr id="19" name=""/>
+          <p:cNvPr id="37" name=""/>
           <p:cNvCxnSpPr/>
           <p:nvPr/>
         </p:nvCxnSpPr>
@@ -10879,6 +11024,7 @@
           <a:lstStyle xmlns:a="http://schemas.openxmlformats.org/drawingml/2006/main"/>
           <a:p xmlns:a="http://schemas.openxmlformats.org/drawingml/2006/main">
             <a:pPr algn="l">
+              <a:buNone/>
               <a:defRPr sz="1275" b="0">
                 <a:solidFill>
                   <a:srgbClr val="606770"/>
@@ -10889,7 +11035,7 @@
               </a:defRPr>
             </a:pPr>
             <a:r>
-              <a:t>SpecStyle | AMD AI DevMaster Track 1 | candidate fd4e45b</a:t>
+              <a:t>SpecStyle | Submitted by guan | AMD AI DevMaster Track 1 | candidate fd4e45b</a:t>
             </a:r>
           </a:p>
         </p:txBody>

</xml_diff>